<commit_message>
v13: inclusion criteria with deck's aesthetic - purple, lilac, clean design
</commit_message>
<xml_diff>
--- a/TFM_Presentacion_Denisa_Antoneac_v13.pptx
+++ b/TFM_Presentacion_Denisa_Antoneac_v13.pptx
@@ -14200,59 +14200,14 @@
       </p:sp>
       <p:sp>
         <p:nvSpPr>
-          <p:cNvPr id="6" name="Rectangle 5"/>
+          <p:cNvPr id="6" name="Oval 5"/>
           <p:cNvSpPr/>
           <p:nvPr/>
         </p:nvSpPr>
         <p:spPr>
           <a:xfrm>
-            <a:off x="750000" y="1620000"/>
-            <a:ext cx="10500000" cy="630000"/>
-          </a:xfrm>
-          <a:prstGeom prst="rect">
-            <a:avLst/>
-          </a:prstGeom>
-          <a:solidFill>
-            <a:srgbClr val="F5F2F9"/>
-          </a:solidFill>
-          <a:ln w="25400">
-            <a:solidFill>
-              <a:srgbClr val="9079C8"/>
-            </a:solidFill>
-          </a:ln>
-        </p:spPr>
-        <p:style>
-          <a:lnRef idx="1">
-            <a:schemeClr val="accent1"/>
-          </a:lnRef>
-          <a:fillRef idx="3">
-            <a:schemeClr val="accent1"/>
-          </a:fillRef>
-          <a:effectRef idx="2">
-            <a:schemeClr val="accent1"/>
-          </a:effectRef>
-          <a:fontRef idx="minor">
-            <a:schemeClr val="lt1"/>
-          </a:fontRef>
-        </p:style>
-        <p:txBody>
-          <a:bodyPr rtlCol="0" anchor="ctr"/>
-          <a:lstStyle/>
-          <a:p>
-            <a:pPr algn="ctr"/>
-          </a:p>
-        </p:txBody>
-      </p:sp>
-      <p:sp>
-        <p:nvSpPr>
-          <p:cNvPr id="7" name="Oval 6"/>
-          <p:cNvSpPr/>
-          <p:nvPr/>
-        </p:nvSpPr>
-        <p:spPr>
-          <a:xfrm>
-            <a:off x="830000" y="1750000"/>
-            <a:ext cx="200000" cy="200000"/>
+            <a:off x="800000" y="1830000"/>
+            <a:ext cx="60000" cy="60000"/>
           </a:xfrm>
           <a:prstGeom prst="ellipse">
             <a:avLst/>
@@ -14288,48 +14243,14 @@
       </p:sp>
       <p:sp>
         <p:nvSpPr>
-          <p:cNvPr id="8" name="TextBox 7"/>
-          <p:cNvSpPr txBox="1"/>
-          <p:nvPr/>
-        </p:nvSpPr>
-        <p:spPr>
-          <a:xfrm>
-            <a:off x="830000" y="1750000"/>
-            <a:ext cx="200000" cy="200000"/>
-          </a:xfrm>
-          <a:prstGeom prst="rect">
-            <a:avLst/>
-          </a:prstGeom>
-          <a:noFill/>
-        </p:spPr>
-        <p:txBody>
-          <a:bodyPr wrap="none" anchor="t">
-            <a:spAutoFit/>
-          </a:bodyPr>
-          <a:lstStyle/>
-          <a:p>
-            <a:pPr algn="ctr"/>
-            <a:r>
-              <a:rPr sz="2200" b="1">
-                <a:solidFill>
-                  <a:srgbClr val="FFFFFF"/>
-                </a:solidFill>
-              </a:rPr>
-              <a:t>A</a:t>
-            </a:r>
-          </a:p>
-        </p:txBody>
-      </p:sp>
-      <p:sp>
-        <p:nvSpPr>
-          <p:cNvPr id="9" name="TextBox 8"/>
-          <p:cNvSpPr txBox="1"/>
-          <p:nvPr/>
-        </p:nvSpPr>
-        <p:spPr>
-          <a:xfrm>
-            <a:off x="1080000" y="1700000"/>
-            <a:ext cx="10100000" cy="570000"/>
+          <p:cNvPr id="7" name="TextBox 6"/>
+          <p:cNvSpPr txBox="1"/>
+          <p:nvPr/>
+        </p:nvSpPr>
+        <p:spPr>
+          <a:xfrm>
+            <a:off x="920000" y="1650000"/>
+            <a:ext cx="10280000" cy="570000"/>
           </a:xfrm>
           <a:prstGeom prst="rect">
             <a:avLst/>
@@ -14344,9 +14265,17 @@
           <a:p>
             <a:pPr algn="l"/>
             <a:r>
+              <a:rPr sz="1800" b="1">
+                <a:solidFill>
+                  <a:srgbClr val="9079C8"/>
+                </a:solidFill>
+              </a:rPr>
+              <a:t>(a) </a:t>
+            </a:r>
+            <a:r>
               <a:rPr sz="1600" b="0">
                 <a:solidFill>
-                  <a:srgbClr val="2E2A3A"/>
+                  <a:srgbClr val="4C4954"/>
                 </a:solidFill>
               </a:rPr>
               <a:t>Meta-análisis cuantitativo en revista científica con peer review</a:t>
@@ -14356,828 +14285,14 @@
       </p:sp>
       <p:sp>
         <p:nvSpPr>
-          <p:cNvPr id="10" name="Rectangle 9"/>
+          <p:cNvPr id="8" name="Oval 7"/>
           <p:cNvSpPr/>
           <p:nvPr/>
         </p:nvSpPr>
         <p:spPr>
           <a:xfrm>
-            <a:off x="750000" y="2240000"/>
-            <a:ext cx="10500000" cy="630000"/>
-          </a:xfrm>
-          <a:prstGeom prst="rect">
-            <a:avLst/>
-          </a:prstGeom>
-          <a:solidFill>
-            <a:srgbClr val="EFF9F9"/>
-          </a:solidFill>
-          <a:ln w="25400">
-            <a:solidFill>
-              <a:srgbClr val="009C9E"/>
-            </a:solidFill>
-          </a:ln>
-        </p:spPr>
-        <p:style>
-          <a:lnRef idx="1">
-            <a:schemeClr val="accent1"/>
-          </a:lnRef>
-          <a:fillRef idx="3">
-            <a:schemeClr val="accent1"/>
-          </a:fillRef>
-          <a:effectRef idx="2">
-            <a:schemeClr val="accent1"/>
-          </a:effectRef>
-          <a:fontRef idx="minor">
-            <a:schemeClr val="lt1"/>
-          </a:fontRef>
-        </p:style>
-        <p:txBody>
-          <a:bodyPr rtlCol="0" anchor="ctr"/>
-          <a:lstStyle/>
-          <a:p>
-            <a:pPr algn="ctr"/>
-          </a:p>
-        </p:txBody>
-      </p:sp>
-      <p:sp>
-        <p:nvSpPr>
-          <p:cNvPr id="11" name="Oval 10"/>
-          <p:cNvSpPr/>
-          <p:nvPr/>
-        </p:nvSpPr>
-        <p:spPr>
-          <a:xfrm>
-            <a:off x="830000" y="2370000"/>
-            <a:ext cx="200000" cy="200000"/>
-          </a:xfrm>
-          <a:prstGeom prst="ellipse">
-            <a:avLst/>
-          </a:prstGeom>
-          <a:solidFill>
-            <a:srgbClr val="009C9E"/>
-          </a:solidFill>
-          <a:ln>
-            <a:noFill/>
-          </a:ln>
-        </p:spPr>
-        <p:style>
-          <a:lnRef idx="1">
-            <a:schemeClr val="accent1"/>
-          </a:lnRef>
-          <a:fillRef idx="3">
-            <a:schemeClr val="accent1"/>
-          </a:fillRef>
-          <a:effectRef idx="2">
-            <a:schemeClr val="accent1"/>
-          </a:effectRef>
-          <a:fontRef idx="minor">
-            <a:schemeClr val="lt1"/>
-          </a:fontRef>
-        </p:style>
-        <p:txBody>
-          <a:bodyPr rtlCol="0" anchor="ctr"/>
-          <a:lstStyle/>
-          <a:p>
-            <a:pPr algn="ctr"/>
-          </a:p>
-        </p:txBody>
-      </p:sp>
-      <p:sp>
-        <p:nvSpPr>
-          <p:cNvPr id="12" name="TextBox 11"/>
-          <p:cNvSpPr txBox="1"/>
-          <p:nvPr/>
-        </p:nvSpPr>
-        <p:spPr>
-          <a:xfrm>
-            <a:off x="830000" y="2370000"/>
-            <a:ext cx="200000" cy="200000"/>
-          </a:xfrm>
-          <a:prstGeom prst="rect">
-            <a:avLst/>
-          </a:prstGeom>
-          <a:noFill/>
-        </p:spPr>
-        <p:txBody>
-          <a:bodyPr wrap="none" anchor="t">
-            <a:spAutoFit/>
-          </a:bodyPr>
-          <a:lstStyle/>
-          <a:p>
-            <a:pPr algn="ctr"/>
-            <a:r>
-              <a:rPr sz="2200" b="1">
-                <a:solidFill>
-                  <a:srgbClr val="FFFFFF"/>
-                </a:solidFill>
-              </a:rPr>
-              <a:t>B</a:t>
-            </a:r>
-          </a:p>
-        </p:txBody>
-      </p:sp>
-      <p:sp>
-        <p:nvSpPr>
-          <p:cNvPr id="13" name="TextBox 12"/>
-          <p:cNvSpPr txBox="1"/>
-          <p:nvPr/>
-        </p:nvSpPr>
-        <p:spPr>
-          <a:xfrm>
-            <a:off x="1080000" y="2320000"/>
-            <a:ext cx="10100000" cy="570000"/>
-          </a:xfrm>
-          <a:prstGeom prst="rect">
-            <a:avLst/>
-          </a:prstGeom>
-          <a:noFill/>
-        </p:spPr>
-        <p:txBody>
-          <a:bodyPr wrap="square">
-            <a:spAutoFit/>
-          </a:bodyPr>
-          <a:lstStyle/>
-          <a:p>
-            <a:pPr algn="l"/>
-            <a:r>
-              <a:rPr sz="1600" b="0">
-                <a:solidFill>
-                  <a:srgbClr val="2E2A3A"/>
-                </a:solidFill>
-              </a:rPr>
-              <a:t>Autoestima o autoconcepto como variable principal</a:t>
-            </a:r>
-          </a:p>
-        </p:txBody>
-      </p:sp>
-      <p:sp>
-        <p:nvSpPr>
-          <p:cNvPr id="14" name="Rectangle 13"/>
-          <p:cNvSpPr/>
-          <p:nvPr/>
-        </p:nvSpPr>
-        <p:spPr>
-          <a:xfrm>
-            <a:off x="750000" y="2860000"/>
-            <a:ext cx="10500000" cy="630000"/>
-          </a:xfrm>
-          <a:prstGeom prst="rect">
-            <a:avLst/>
-          </a:prstGeom>
-          <a:solidFill>
-            <a:srgbClr val="FEF2F2"/>
-          </a:solidFill>
-          <a:ln w="25400">
-            <a:solidFill>
-              <a:srgbClr val="E86C6C"/>
-            </a:solidFill>
-          </a:ln>
-        </p:spPr>
-        <p:style>
-          <a:lnRef idx="1">
-            <a:schemeClr val="accent1"/>
-          </a:lnRef>
-          <a:fillRef idx="3">
-            <a:schemeClr val="accent1"/>
-          </a:fillRef>
-          <a:effectRef idx="2">
-            <a:schemeClr val="accent1"/>
-          </a:effectRef>
-          <a:fontRef idx="minor">
-            <a:schemeClr val="lt1"/>
-          </a:fontRef>
-        </p:style>
-        <p:txBody>
-          <a:bodyPr rtlCol="0" anchor="ctr"/>
-          <a:lstStyle/>
-          <a:p>
-            <a:pPr algn="ctr"/>
-          </a:p>
-        </p:txBody>
-      </p:sp>
-      <p:sp>
-        <p:nvSpPr>
-          <p:cNvPr id="15" name="Oval 14"/>
-          <p:cNvSpPr/>
-          <p:nvPr/>
-        </p:nvSpPr>
-        <p:spPr>
-          <a:xfrm>
-            <a:off x="830000" y="2990000"/>
-            <a:ext cx="200000" cy="200000"/>
-          </a:xfrm>
-          <a:prstGeom prst="ellipse">
-            <a:avLst/>
-          </a:prstGeom>
-          <a:solidFill>
-            <a:srgbClr val="E86C6C"/>
-          </a:solidFill>
-          <a:ln>
-            <a:noFill/>
-          </a:ln>
-        </p:spPr>
-        <p:style>
-          <a:lnRef idx="1">
-            <a:schemeClr val="accent1"/>
-          </a:lnRef>
-          <a:fillRef idx="3">
-            <a:schemeClr val="accent1"/>
-          </a:fillRef>
-          <a:effectRef idx="2">
-            <a:schemeClr val="accent1"/>
-          </a:effectRef>
-          <a:fontRef idx="minor">
-            <a:schemeClr val="lt1"/>
-          </a:fontRef>
-        </p:style>
-        <p:txBody>
-          <a:bodyPr rtlCol="0" anchor="ctr"/>
-          <a:lstStyle/>
-          <a:p>
-            <a:pPr algn="ctr"/>
-          </a:p>
-        </p:txBody>
-      </p:sp>
-      <p:sp>
-        <p:nvSpPr>
-          <p:cNvPr id="16" name="TextBox 15"/>
-          <p:cNvSpPr txBox="1"/>
-          <p:nvPr/>
-        </p:nvSpPr>
-        <p:spPr>
-          <a:xfrm>
-            <a:off x="830000" y="2990000"/>
-            <a:ext cx="200000" cy="200000"/>
-          </a:xfrm>
-          <a:prstGeom prst="rect">
-            <a:avLst/>
-          </a:prstGeom>
-          <a:noFill/>
-        </p:spPr>
-        <p:txBody>
-          <a:bodyPr wrap="none" anchor="t">
-            <a:spAutoFit/>
-          </a:bodyPr>
-          <a:lstStyle/>
-          <a:p>
-            <a:pPr algn="ctr"/>
-            <a:r>
-              <a:rPr sz="2200" b="1">
-                <a:solidFill>
-                  <a:srgbClr val="FFFFFF"/>
-                </a:solidFill>
-              </a:rPr>
-              <a:t>C</a:t>
-            </a:r>
-          </a:p>
-        </p:txBody>
-      </p:sp>
-      <p:sp>
-        <p:nvSpPr>
-          <p:cNvPr id="17" name="TextBox 16"/>
-          <p:cNvSpPr txBox="1"/>
-          <p:nvPr/>
-        </p:nvSpPr>
-        <p:spPr>
-          <a:xfrm>
-            <a:off x="1080000" y="2940000"/>
-            <a:ext cx="10100000" cy="570000"/>
-          </a:xfrm>
-          <a:prstGeom prst="rect">
-            <a:avLst/>
-          </a:prstGeom>
-          <a:noFill/>
-        </p:spPr>
-        <p:txBody>
-          <a:bodyPr wrap="square">
-            <a:spAutoFit/>
-          </a:bodyPr>
-          <a:lstStyle/>
-          <a:p>
-            <a:pPr algn="l"/>
-            <a:r>
-              <a:rPr sz="1600" b="0">
-                <a:solidFill>
-                  <a:srgbClr val="2E2A3A"/>
-                </a:solidFill>
-              </a:rPr>
-              <a:t>Indicador de bienestar adicional (subjetivo, psicológico, HRQoL o salud mental)</a:t>
-            </a:r>
-          </a:p>
-        </p:txBody>
-      </p:sp>
-      <p:sp>
-        <p:nvSpPr>
-          <p:cNvPr id="18" name="Rectangle 17"/>
-          <p:cNvSpPr/>
-          <p:nvPr/>
-        </p:nvSpPr>
-        <p:spPr>
-          <a:xfrm>
-            <a:off x="750000" y="3480000"/>
-            <a:ext cx="10500000" cy="630000"/>
-          </a:xfrm>
-          <a:prstGeom prst="rect">
-            <a:avLst/>
-          </a:prstGeom>
-          <a:solidFill>
-            <a:srgbClr val="F5F9F6"/>
-          </a:solidFill>
-          <a:ln w="25400">
-            <a:solidFill>
-              <a:srgbClr val="7AA88D"/>
-            </a:solidFill>
-          </a:ln>
-        </p:spPr>
-        <p:style>
-          <a:lnRef idx="1">
-            <a:schemeClr val="accent1"/>
-          </a:lnRef>
-          <a:fillRef idx="3">
-            <a:schemeClr val="accent1"/>
-          </a:fillRef>
-          <a:effectRef idx="2">
-            <a:schemeClr val="accent1"/>
-          </a:effectRef>
-          <a:fontRef idx="minor">
-            <a:schemeClr val="lt1"/>
-          </a:fontRef>
-        </p:style>
-        <p:txBody>
-          <a:bodyPr rtlCol="0" anchor="ctr"/>
-          <a:lstStyle/>
-          <a:p>
-            <a:pPr algn="ctr"/>
-          </a:p>
-        </p:txBody>
-      </p:sp>
-      <p:sp>
-        <p:nvSpPr>
-          <p:cNvPr id="19" name="Oval 18"/>
-          <p:cNvSpPr/>
-          <p:nvPr/>
-        </p:nvSpPr>
-        <p:spPr>
-          <a:xfrm>
-            <a:off x="830000" y="3610000"/>
-            <a:ext cx="200000" cy="200000"/>
-          </a:xfrm>
-          <a:prstGeom prst="ellipse">
-            <a:avLst/>
-          </a:prstGeom>
-          <a:solidFill>
-            <a:srgbClr val="7AA88D"/>
-          </a:solidFill>
-          <a:ln>
-            <a:noFill/>
-          </a:ln>
-        </p:spPr>
-        <p:style>
-          <a:lnRef idx="1">
-            <a:schemeClr val="accent1"/>
-          </a:lnRef>
-          <a:fillRef idx="3">
-            <a:schemeClr val="accent1"/>
-          </a:fillRef>
-          <a:effectRef idx="2">
-            <a:schemeClr val="accent1"/>
-          </a:effectRef>
-          <a:fontRef idx="minor">
-            <a:schemeClr val="lt1"/>
-          </a:fontRef>
-        </p:style>
-        <p:txBody>
-          <a:bodyPr rtlCol="0" anchor="ctr"/>
-          <a:lstStyle/>
-          <a:p>
-            <a:pPr algn="ctr"/>
-          </a:p>
-        </p:txBody>
-      </p:sp>
-      <p:sp>
-        <p:nvSpPr>
-          <p:cNvPr id="20" name="TextBox 19"/>
-          <p:cNvSpPr txBox="1"/>
-          <p:nvPr/>
-        </p:nvSpPr>
-        <p:spPr>
-          <a:xfrm>
-            <a:off x="830000" y="3610000"/>
-            <a:ext cx="200000" cy="200000"/>
-          </a:xfrm>
-          <a:prstGeom prst="rect">
-            <a:avLst/>
-          </a:prstGeom>
-          <a:noFill/>
-        </p:spPr>
-        <p:txBody>
-          <a:bodyPr wrap="none" anchor="t">
-            <a:spAutoFit/>
-          </a:bodyPr>
-          <a:lstStyle/>
-          <a:p>
-            <a:pPr algn="ctr"/>
-            <a:r>
-              <a:rPr sz="2200" b="1">
-                <a:solidFill>
-                  <a:srgbClr val="FFFFFF"/>
-                </a:solidFill>
-              </a:rPr>
-              <a:t>D</a:t>
-            </a:r>
-          </a:p>
-        </p:txBody>
-      </p:sp>
-      <p:sp>
-        <p:nvSpPr>
-          <p:cNvPr id="21" name="TextBox 20"/>
-          <p:cNvSpPr txBox="1"/>
-          <p:nvPr/>
-        </p:nvSpPr>
-        <p:spPr>
-          <a:xfrm>
-            <a:off x="1080000" y="3560000"/>
-            <a:ext cx="10100000" cy="570000"/>
-          </a:xfrm>
-          <a:prstGeom prst="rect">
-            <a:avLst/>
-          </a:prstGeom>
-          <a:noFill/>
-        </p:spPr>
-        <p:txBody>
-          <a:bodyPr wrap="square">
-            <a:spAutoFit/>
-          </a:bodyPr>
-          <a:lstStyle/>
-          <a:p>
-            <a:pPr algn="l"/>
-            <a:r>
-              <a:rPr sz="1600" b="0">
-                <a:solidFill>
-                  <a:srgbClr val="2E2A3A"/>
-                </a:solidFill>
-              </a:rPr>
-              <a:t>Población clínica/salud ≥75% (o análisis estratificados)</a:t>
-            </a:r>
-          </a:p>
-        </p:txBody>
-      </p:sp>
-      <p:sp>
-        <p:nvSpPr>
-          <p:cNvPr id="22" name="Rectangle 21"/>
-          <p:cNvSpPr/>
-          <p:nvPr/>
-        </p:nvSpPr>
-        <p:spPr>
-          <a:xfrm>
-            <a:off x="750000" y="4100000"/>
-            <a:ext cx="10500000" cy="630000"/>
-          </a:xfrm>
-          <a:prstGeom prst="rect">
-            <a:avLst/>
-          </a:prstGeom>
-          <a:solidFill>
-            <a:srgbClr val="FEF7ED"/>
-          </a:solidFill>
-          <a:ln w="25400">
-            <a:solidFill>
-              <a:srgbClr val="D4A54D"/>
-            </a:solidFill>
-          </a:ln>
-        </p:spPr>
-        <p:style>
-          <a:lnRef idx="1">
-            <a:schemeClr val="accent1"/>
-          </a:lnRef>
-          <a:fillRef idx="3">
-            <a:schemeClr val="accent1"/>
-          </a:fillRef>
-          <a:effectRef idx="2">
-            <a:schemeClr val="accent1"/>
-          </a:effectRef>
-          <a:fontRef idx="minor">
-            <a:schemeClr val="lt1"/>
-          </a:fontRef>
-        </p:style>
-        <p:txBody>
-          <a:bodyPr rtlCol="0" anchor="ctr"/>
-          <a:lstStyle/>
-          <a:p>
-            <a:pPr algn="ctr"/>
-          </a:p>
-        </p:txBody>
-      </p:sp>
-      <p:sp>
-        <p:nvSpPr>
-          <p:cNvPr id="23" name="Oval 22"/>
-          <p:cNvSpPr/>
-          <p:nvPr/>
-        </p:nvSpPr>
-        <p:spPr>
-          <a:xfrm>
-            <a:off x="830000" y="4230000"/>
-            <a:ext cx="200000" cy="200000"/>
-          </a:xfrm>
-          <a:prstGeom prst="ellipse">
-            <a:avLst/>
-          </a:prstGeom>
-          <a:solidFill>
-            <a:srgbClr val="D4A54D"/>
-          </a:solidFill>
-          <a:ln>
-            <a:noFill/>
-          </a:ln>
-        </p:spPr>
-        <p:style>
-          <a:lnRef idx="1">
-            <a:schemeClr val="accent1"/>
-          </a:lnRef>
-          <a:fillRef idx="3">
-            <a:schemeClr val="accent1"/>
-          </a:fillRef>
-          <a:effectRef idx="2">
-            <a:schemeClr val="accent1"/>
-          </a:effectRef>
-          <a:fontRef idx="minor">
-            <a:schemeClr val="lt1"/>
-          </a:fontRef>
-        </p:style>
-        <p:txBody>
-          <a:bodyPr rtlCol="0" anchor="ctr"/>
-          <a:lstStyle/>
-          <a:p>
-            <a:pPr algn="ctr"/>
-          </a:p>
-        </p:txBody>
-      </p:sp>
-      <p:sp>
-        <p:nvSpPr>
-          <p:cNvPr id="24" name="TextBox 23"/>
-          <p:cNvSpPr txBox="1"/>
-          <p:nvPr/>
-        </p:nvSpPr>
-        <p:spPr>
-          <a:xfrm>
-            <a:off x="830000" y="4230000"/>
-            <a:ext cx="200000" cy="200000"/>
-          </a:xfrm>
-          <a:prstGeom prst="rect">
-            <a:avLst/>
-          </a:prstGeom>
-          <a:noFill/>
-        </p:spPr>
-        <p:txBody>
-          <a:bodyPr wrap="none" anchor="t">
-            <a:spAutoFit/>
-          </a:bodyPr>
-          <a:lstStyle/>
-          <a:p>
-            <a:pPr algn="ctr"/>
-            <a:r>
-              <a:rPr sz="2200" b="1">
-                <a:solidFill>
-                  <a:srgbClr val="FFFFFF"/>
-                </a:solidFill>
-              </a:rPr>
-              <a:t>E</a:t>
-            </a:r>
-          </a:p>
-        </p:txBody>
-      </p:sp>
-      <p:sp>
-        <p:nvSpPr>
-          <p:cNvPr id="25" name="TextBox 24"/>
-          <p:cNvSpPr txBox="1"/>
-          <p:nvPr/>
-        </p:nvSpPr>
-        <p:spPr>
-          <a:xfrm>
-            <a:off x="1080000" y="4180000"/>
-            <a:ext cx="10100000" cy="570000"/>
-          </a:xfrm>
-          <a:prstGeom prst="rect">
-            <a:avLst/>
-          </a:prstGeom>
-          <a:noFill/>
-        </p:spPr>
-        <p:txBody>
-          <a:bodyPr wrap="square">
-            <a:spAutoFit/>
-          </a:bodyPr>
-          <a:lstStyle/>
-          <a:p>
-            <a:pPr algn="l"/>
-            <a:r>
-              <a:rPr sz="1600" b="0">
-                <a:solidFill>
-                  <a:srgbClr val="2E2A3A"/>
-                </a:solidFill>
-              </a:rPr>
-              <a:t>Publicado en inglés o español</a:t>
-            </a:r>
-          </a:p>
-        </p:txBody>
-      </p:sp>
-      <p:sp>
-        <p:nvSpPr>
-          <p:cNvPr id="26" name="Rectangle 25"/>
-          <p:cNvSpPr/>
-          <p:nvPr/>
-        </p:nvSpPr>
-        <p:spPr>
-          <a:xfrm>
-            <a:off x="750000" y="4720000"/>
-            <a:ext cx="10500000" cy="630000"/>
-          </a:xfrm>
-          <a:prstGeom prst="rect">
-            <a:avLst/>
-          </a:prstGeom>
-          <a:solidFill>
-            <a:srgbClr val="FDF4F9"/>
-          </a:solidFill>
-          <a:ln w="25400">
-            <a:solidFill>
-              <a:srgbClr val="B87DA8"/>
-            </a:solidFill>
-          </a:ln>
-        </p:spPr>
-        <p:style>
-          <a:lnRef idx="1">
-            <a:schemeClr val="accent1"/>
-          </a:lnRef>
-          <a:fillRef idx="3">
-            <a:schemeClr val="accent1"/>
-          </a:fillRef>
-          <a:effectRef idx="2">
-            <a:schemeClr val="accent1"/>
-          </a:effectRef>
-          <a:fontRef idx="minor">
-            <a:schemeClr val="lt1"/>
-          </a:fontRef>
-        </p:style>
-        <p:txBody>
-          <a:bodyPr rtlCol="0" anchor="ctr"/>
-          <a:lstStyle/>
-          <a:p>
-            <a:pPr algn="ctr"/>
-          </a:p>
-        </p:txBody>
-      </p:sp>
-      <p:sp>
-        <p:nvSpPr>
-          <p:cNvPr id="27" name="Oval 26"/>
-          <p:cNvSpPr/>
-          <p:nvPr/>
-        </p:nvSpPr>
-        <p:spPr>
-          <a:xfrm>
-            <a:off x="830000" y="4850000"/>
-            <a:ext cx="200000" cy="200000"/>
-          </a:xfrm>
-          <a:prstGeom prst="ellipse">
-            <a:avLst/>
-          </a:prstGeom>
-          <a:solidFill>
-            <a:srgbClr val="B87DA8"/>
-          </a:solidFill>
-          <a:ln>
-            <a:noFill/>
-          </a:ln>
-        </p:spPr>
-        <p:style>
-          <a:lnRef idx="1">
-            <a:schemeClr val="accent1"/>
-          </a:lnRef>
-          <a:fillRef idx="3">
-            <a:schemeClr val="accent1"/>
-          </a:fillRef>
-          <a:effectRef idx="2">
-            <a:schemeClr val="accent1"/>
-          </a:effectRef>
-          <a:fontRef idx="minor">
-            <a:schemeClr val="lt1"/>
-          </a:fontRef>
-        </p:style>
-        <p:txBody>
-          <a:bodyPr rtlCol="0" anchor="ctr"/>
-          <a:lstStyle/>
-          <a:p>
-            <a:pPr algn="ctr"/>
-          </a:p>
-        </p:txBody>
-      </p:sp>
-      <p:sp>
-        <p:nvSpPr>
-          <p:cNvPr id="28" name="TextBox 27"/>
-          <p:cNvSpPr txBox="1"/>
-          <p:nvPr/>
-        </p:nvSpPr>
-        <p:spPr>
-          <a:xfrm>
-            <a:off x="830000" y="4850000"/>
-            <a:ext cx="200000" cy="200000"/>
-          </a:xfrm>
-          <a:prstGeom prst="rect">
-            <a:avLst/>
-          </a:prstGeom>
-          <a:noFill/>
-        </p:spPr>
-        <p:txBody>
-          <a:bodyPr wrap="none" anchor="t">
-            <a:spAutoFit/>
-          </a:bodyPr>
-          <a:lstStyle/>
-          <a:p>
-            <a:pPr algn="ctr"/>
-            <a:r>
-              <a:rPr sz="2200" b="1">
-                <a:solidFill>
-                  <a:srgbClr val="FFFFFF"/>
-                </a:solidFill>
-              </a:rPr>
-              <a:t>F</a:t>
-            </a:r>
-          </a:p>
-        </p:txBody>
-      </p:sp>
-      <p:sp>
-        <p:nvSpPr>
-          <p:cNvPr id="29" name="TextBox 28"/>
-          <p:cNvSpPr txBox="1"/>
-          <p:nvPr/>
-        </p:nvSpPr>
-        <p:spPr>
-          <a:xfrm>
-            <a:off x="1080000" y="4800000"/>
-            <a:ext cx="10100000" cy="570000"/>
-          </a:xfrm>
-          <a:prstGeom prst="rect">
-            <a:avLst/>
-          </a:prstGeom>
-          <a:noFill/>
-        </p:spPr>
-        <p:txBody>
-          <a:bodyPr wrap="square">
-            <a:spAutoFit/>
-          </a:bodyPr>
-          <a:lstStyle/>
-          <a:p>
-            <a:pPr algn="l"/>
-            <a:r>
-              <a:rPr sz="1600" b="0">
-                <a:solidFill>
-                  <a:srgbClr val="2E2A3A"/>
-                </a:solidFill>
-              </a:rPr>
-              <a:t>Publicado entre 1 enero 2016 y 25 mayo 2026</a:t>
-            </a:r>
-          </a:p>
-        </p:txBody>
-      </p:sp>
-      <p:sp>
-        <p:nvSpPr>
-          <p:cNvPr id="30" name="TextBox 29"/>
-          <p:cNvSpPr txBox="1"/>
-          <p:nvPr/>
-        </p:nvSpPr>
-        <p:spPr>
-          <a:xfrm>
-            <a:off x="749808" y="6455664"/>
-            <a:ext cx="6858000" cy="228600"/>
-          </a:xfrm>
-          <a:prstGeom prst="rect">
-            <a:avLst/>
-          </a:prstGeom>
-          <a:noFill/>
-        </p:spPr>
-        <p:txBody>
-          <a:bodyPr wrap="square">
-            <a:spAutoFit/>
-          </a:bodyPr>
-          <a:lstStyle/>
-          <a:p>
-            <a:pPr algn="l"/>
-            <a:r>
-              <a:rPr sz="1000" b="0">
-                <a:solidFill>
-                  <a:srgbClr val="9C99A6"/>
-                </a:solidFill>
-              </a:rPr>
-              <a:t>Autoestima, autoconcepto y bienestar   -   D. Antoneac</a:t>
-            </a:r>
-          </a:p>
-        </p:txBody>
-      </p:sp>
-      <p:sp>
-        <p:nvSpPr>
-          <p:cNvPr id="31" name="Oval 30"/>
-          <p:cNvSpPr/>
-          <p:nvPr/>
-        </p:nvSpPr>
-        <p:spPr>
-          <a:xfrm>
-            <a:off x="10561320" y="6519672"/>
-            <a:ext cx="82296" cy="82296"/>
+            <a:off x="800000" y="2480000"/>
+            <a:ext cx="60000" cy="60000"/>
           </a:xfrm>
           <a:prstGeom prst="ellipse">
             <a:avLst/>
@@ -15213,7 +14328,681 @@
       </p:sp>
       <p:sp>
         <p:nvSpPr>
-          <p:cNvPr id="32" name="TextBox 31"/>
+          <p:cNvPr id="9" name="Rectangle 8"/>
+          <p:cNvSpPr/>
+          <p:nvPr/>
+        </p:nvSpPr>
+        <p:spPr>
+          <a:xfrm>
+            <a:off x="900000" y="2270000"/>
+            <a:ext cx="10300000" cy="13716"/>
+          </a:xfrm>
+          <a:prstGeom prst="rect">
+            <a:avLst/>
+          </a:prstGeom>
+          <a:solidFill>
+            <a:srgbClr val="DFD8EC"/>
+          </a:solidFill>
+          <a:ln>
+            <a:noFill/>
+          </a:ln>
+        </p:spPr>
+        <p:style>
+          <a:lnRef idx="1">
+            <a:schemeClr val="accent1"/>
+          </a:lnRef>
+          <a:fillRef idx="3">
+            <a:schemeClr val="accent1"/>
+          </a:fillRef>
+          <a:effectRef idx="2">
+            <a:schemeClr val="accent1"/>
+          </a:effectRef>
+          <a:fontRef idx="minor">
+            <a:schemeClr val="lt1"/>
+          </a:fontRef>
+        </p:style>
+        <p:txBody>
+          <a:bodyPr rtlCol="0" anchor="ctr"/>
+          <a:lstStyle/>
+          <a:p>
+            <a:pPr algn="ctr"/>
+          </a:p>
+        </p:txBody>
+      </p:sp>
+      <p:sp>
+        <p:nvSpPr>
+          <p:cNvPr id="10" name="TextBox 9"/>
+          <p:cNvSpPr txBox="1"/>
+          <p:nvPr/>
+        </p:nvSpPr>
+        <p:spPr>
+          <a:xfrm>
+            <a:off x="920000" y="2300000"/>
+            <a:ext cx="10280000" cy="570000"/>
+          </a:xfrm>
+          <a:prstGeom prst="rect">
+            <a:avLst/>
+          </a:prstGeom>
+          <a:noFill/>
+        </p:spPr>
+        <p:txBody>
+          <a:bodyPr wrap="square">
+            <a:spAutoFit/>
+          </a:bodyPr>
+          <a:lstStyle/>
+          <a:p>
+            <a:pPr algn="l"/>
+            <a:r>
+              <a:rPr sz="1800" b="1">
+                <a:solidFill>
+                  <a:srgbClr val="9079C8"/>
+                </a:solidFill>
+              </a:rPr>
+              <a:t>(b) </a:t>
+            </a:r>
+            <a:r>
+              <a:rPr sz="1600" b="0">
+                <a:solidFill>
+                  <a:srgbClr val="4C4954"/>
+                </a:solidFill>
+              </a:rPr>
+              <a:t>Autoestima o autoconcepto como variable principal</a:t>
+            </a:r>
+          </a:p>
+        </p:txBody>
+      </p:sp>
+      <p:sp>
+        <p:nvSpPr>
+          <p:cNvPr id="11" name="Oval 10"/>
+          <p:cNvSpPr/>
+          <p:nvPr/>
+        </p:nvSpPr>
+        <p:spPr>
+          <a:xfrm>
+            <a:off x="800000" y="3130000"/>
+            <a:ext cx="60000" cy="60000"/>
+          </a:xfrm>
+          <a:prstGeom prst="ellipse">
+            <a:avLst/>
+          </a:prstGeom>
+          <a:solidFill>
+            <a:srgbClr val="9079C8"/>
+          </a:solidFill>
+          <a:ln>
+            <a:noFill/>
+          </a:ln>
+        </p:spPr>
+        <p:style>
+          <a:lnRef idx="1">
+            <a:schemeClr val="accent1"/>
+          </a:lnRef>
+          <a:fillRef idx="3">
+            <a:schemeClr val="accent1"/>
+          </a:fillRef>
+          <a:effectRef idx="2">
+            <a:schemeClr val="accent1"/>
+          </a:effectRef>
+          <a:fontRef idx="minor">
+            <a:schemeClr val="lt1"/>
+          </a:fontRef>
+        </p:style>
+        <p:txBody>
+          <a:bodyPr rtlCol="0" anchor="ctr"/>
+          <a:lstStyle/>
+          <a:p>
+            <a:pPr algn="ctr"/>
+          </a:p>
+        </p:txBody>
+      </p:sp>
+      <p:sp>
+        <p:nvSpPr>
+          <p:cNvPr id="12" name="Rectangle 11"/>
+          <p:cNvSpPr/>
+          <p:nvPr/>
+        </p:nvSpPr>
+        <p:spPr>
+          <a:xfrm>
+            <a:off x="900000" y="2920000"/>
+            <a:ext cx="10300000" cy="13716"/>
+          </a:xfrm>
+          <a:prstGeom prst="rect">
+            <a:avLst/>
+          </a:prstGeom>
+          <a:solidFill>
+            <a:srgbClr val="DFD8EC"/>
+          </a:solidFill>
+          <a:ln>
+            <a:noFill/>
+          </a:ln>
+        </p:spPr>
+        <p:style>
+          <a:lnRef idx="1">
+            <a:schemeClr val="accent1"/>
+          </a:lnRef>
+          <a:fillRef idx="3">
+            <a:schemeClr val="accent1"/>
+          </a:fillRef>
+          <a:effectRef idx="2">
+            <a:schemeClr val="accent1"/>
+          </a:effectRef>
+          <a:fontRef idx="minor">
+            <a:schemeClr val="lt1"/>
+          </a:fontRef>
+        </p:style>
+        <p:txBody>
+          <a:bodyPr rtlCol="0" anchor="ctr"/>
+          <a:lstStyle/>
+          <a:p>
+            <a:pPr algn="ctr"/>
+          </a:p>
+        </p:txBody>
+      </p:sp>
+      <p:sp>
+        <p:nvSpPr>
+          <p:cNvPr id="13" name="TextBox 12"/>
+          <p:cNvSpPr txBox="1"/>
+          <p:nvPr/>
+        </p:nvSpPr>
+        <p:spPr>
+          <a:xfrm>
+            <a:off x="920000" y="2950000"/>
+            <a:ext cx="10280000" cy="570000"/>
+          </a:xfrm>
+          <a:prstGeom prst="rect">
+            <a:avLst/>
+          </a:prstGeom>
+          <a:noFill/>
+        </p:spPr>
+        <p:txBody>
+          <a:bodyPr wrap="square">
+            <a:spAutoFit/>
+          </a:bodyPr>
+          <a:lstStyle/>
+          <a:p>
+            <a:pPr algn="l"/>
+            <a:r>
+              <a:rPr sz="1800" b="1">
+                <a:solidFill>
+                  <a:srgbClr val="9079C8"/>
+                </a:solidFill>
+              </a:rPr>
+              <a:t>(c) </a:t>
+            </a:r>
+            <a:r>
+              <a:rPr sz="1600" b="0">
+                <a:solidFill>
+                  <a:srgbClr val="4C4954"/>
+                </a:solidFill>
+              </a:rPr>
+              <a:t>Indicador de bienestar adicional (subjetivo, psicológico, HRQoL o salud mental)</a:t>
+            </a:r>
+          </a:p>
+        </p:txBody>
+      </p:sp>
+      <p:sp>
+        <p:nvSpPr>
+          <p:cNvPr id="14" name="Oval 13"/>
+          <p:cNvSpPr/>
+          <p:nvPr/>
+        </p:nvSpPr>
+        <p:spPr>
+          <a:xfrm>
+            <a:off x="800000" y="3780000"/>
+            <a:ext cx="60000" cy="60000"/>
+          </a:xfrm>
+          <a:prstGeom prst="ellipse">
+            <a:avLst/>
+          </a:prstGeom>
+          <a:solidFill>
+            <a:srgbClr val="9079C8"/>
+          </a:solidFill>
+          <a:ln>
+            <a:noFill/>
+          </a:ln>
+        </p:spPr>
+        <p:style>
+          <a:lnRef idx="1">
+            <a:schemeClr val="accent1"/>
+          </a:lnRef>
+          <a:fillRef idx="3">
+            <a:schemeClr val="accent1"/>
+          </a:fillRef>
+          <a:effectRef idx="2">
+            <a:schemeClr val="accent1"/>
+          </a:effectRef>
+          <a:fontRef idx="minor">
+            <a:schemeClr val="lt1"/>
+          </a:fontRef>
+        </p:style>
+        <p:txBody>
+          <a:bodyPr rtlCol="0" anchor="ctr"/>
+          <a:lstStyle/>
+          <a:p>
+            <a:pPr algn="ctr"/>
+          </a:p>
+        </p:txBody>
+      </p:sp>
+      <p:sp>
+        <p:nvSpPr>
+          <p:cNvPr id="15" name="Rectangle 14"/>
+          <p:cNvSpPr/>
+          <p:nvPr/>
+        </p:nvSpPr>
+        <p:spPr>
+          <a:xfrm>
+            <a:off x="900000" y="3570000"/>
+            <a:ext cx="10300000" cy="13716"/>
+          </a:xfrm>
+          <a:prstGeom prst="rect">
+            <a:avLst/>
+          </a:prstGeom>
+          <a:solidFill>
+            <a:srgbClr val="DFD8EC"/>
+          </a:solidFill>
+          <a:ln>
+            <a:noFill/>
+          </a:ln>
+        </p:spPr>
+        <p:style>
+          <a:lnRef idx="1">
+            <a:schemeClr val="accent1"/>
+          </a:lnRef>
+          <a:fillRef idx="3">
+            <a:schemeClr val="accent1"/>
+          </a:fillRef>
+          <a:effectRef idx="2">
+            <a:schemeClr val="accent1"/>
+          </a:effectRef>
+          <a:fontRef idx="minor">
+            <a:schemeClr val="lt1"/>
+          </a:fontRef>
+        </p:style>
+        <p:txBody>
+          <a:bodyPr rtlCol="0" anchor="ctr"/>
+          <a:lstStyle/>
+          <a:p>
+            <a:pPr algn="ctr"/>
+          </a:p>
+        </p:txBody>
+      </p:sp>
+      <p:sp>
+        <p:nvSpPr>
+          <p:cNvPr id="16" name="TextBox 15"/>
+          <p:cNvSpPr txBox="1"/>
+          <p:nvPr/>
+        </p:nvSpPr>
+        <p:spPr>
+          <a:xfrm>
+            <a:off x="920000" y="3600000"/>
+            <a:ext cx="10280000" cy="570000"/>
+          </a:xfrm>
+          <a:prstGeom prst="rect">
+            <a:avLst/>
+          </a:prstGeom>
+          <a:noFill/>
+        </p:spPr>
+        <p:txBody>
+          <a:bodyPr wrap="square">
+            <a:spAutoFit/>
+          </a:bodyPr>
+          <a:lstStyle/>
+          <a:p>
+            <a:pPr algn="l"/>
+            <a:r>
+              <a:rPr sz="1800" b="1">
+                <a:solidFill>
+                  <a:srgbClr val="9079C8"/>
+                </a:solidFill>
+              </a:rPr>
+              <a:t>(d) </a:t>
+            </a:r>
+            <a:r>
+              <a:rPr sz="1600" b="0">
+                <a:solidFill>
+                  <a:srgbClr val="4C4954"/>
+                </a:solidFill>
+              </a:rPr>
+              <a:t>Población clínica/salud ≥75% (o análisis estratificados)</a:t>
+            </a:r>
+          </a:p>
+        </p:txBody>
+      </p:sp>
+      <p:sp>
+        <p:nvSpPr>
+          <p:cNvPr id="17" name="Oval 16"/>
+          <p:cNvSpPr/>
+          <p:nvPr/>
+        </p:nvSpPr>
+        <p:spPr>
+          <a:xfrm>
+            <a:off x="800000" y="4430000"/>
+            <a:ext cx="60000" cy="60000"/>
+          </a:xfrm>
+          <a:prstGeom prst="ellipse">
+            <a:avLst/>
+          </a:prstGeom>
+          <a:solidFill>
+            <a:srgbClr val="9079C8"/>
+          </a:solidFill>
+          <a:ln>
+            <a:noFill/>
+          </a:ln>
+        </p:spPr>
+        <p:style>
+          <a:lnRef idx="1">
+            <a:schemeClr val="accent1"/>
+          </a:lnRef>
+          <a:fillRef idx="3">
+            <a:schemeClr val="accent1"/>
+          </a:fillRef>
+          <a:effectRef idx="2">
+            <a:schemeClr val="accent1"/>
+          </a:effectRef>
+          <a:fontRef idx="minor">
+            <a:schemeClr val="lt1"/>
+          </a:fontRef>
+        </p:style>
+        <p:txBody>
+          <a:bodyPr rtlCol="0" anchor="ctr"/>
+          <a:lstStyle/>
+          <a:p>
+            <a:pPr algn="ctr"/>
+          </a:p>
+        </p:txBody>
+      </p:sp>
+      <p:sp>
+        <p:nvSpPr>
+          <p:cNvPr id="18" name="Rectangle 17"/>
+          <p:cNvSpPr/>
+          <p:nvPr/>
+        </p:nvSpPr>
+        <p:spPr>
+          <a:xfrm>
+            <a:off x="900000" y="4220000"/>
+            <a:ext cx="10300000" cy="13716"/>
+          </a:xfrm>
+          <a:prstGeom prst="rect">
+            <a:avLst/>
+          </a:prstGeom>
+          <a:solidFill>
+            <a:srgbClr val="DFD8EC"/>
+          </a:solidFill>
+          <a:ln>
+            <a:noFill/>
+          </a:ln>
+        </p:spPr>
+        <p:style>
+          <a:lnRef idx="1">
+            <a:schemeClr val="accent1"/>
+          </a:lnRef>
+          <a:fillRef idx="3">
+            <a:schemeClr val="accent1"/>
+          </a:fillRef>
+          <a:effectRef idx="2">
+            <a:schemeClr val="accent1"/>
+          </a:effectRef>
+          <a:fontRef idx="minor">
+            <a:schemeClr val="lt1"/>
+          </a:fontRef>
+        </p:style>
+        <p:txBody>
+          <a:bodyPr rtlCol="0" anchor="ctr"/>
+          <a:lstStyle/>
+          <a:p>
+            <a:pPr algn="ctr"/>
+          </a:p>
+        </p:txBody>
+      </p:sp>
+      <p:sp>
+        <p:nvSpPr>
+          <p:cNvPr id="19" name="TextBox 18"/>
+          <p:cNvSpPr txBox="1"/>
+          <p:nvPr/>
+        </p:nvSpPr>
+        <p:spPr>
+          <a:xfrm>
+            <a:off x="920000" y="4250000"/>
+            <a:ext cx="10280000" cy="570000"/>
+          </a:xfrm>
+          <a:prstGeom prst="rect">
+            <a:avLst/>
+          </a:prstGeom>
+          <a:noFill/>
+        </p:spPr>
+        <p:txBody>
+          <a:bodyPr wrap="square">
+            <a:spAutoFit/>
+          </a:bodyPr>
+          <a:lstStyle/>
+          <a:p>
+            <a:pPr algn="l"/>
+            <a:r>
+              <a:rPr sz="1800" b="1">
+                <a:solidFill>
+                  <a:srgbClr val="9079C8"/>
+                </a:solidFill>
+              </a:rPr>
+              <a:t>(e) </a:t>
+            </a:r>
+            <a:r>
+              <a:rPr sz="1600" b="0">
+                <a:solidFill>
+                  <a:srgbClr val="4C4954"/>
+                </a:solidFill>
+              </a:rPr>
+              <a:t>Publicado en inglés o español</a:t>
+            </a:r>
+          </a:p>
+        </p:txBody>
+      </p:sp>
+      <p:sp>
+        <p:nvSpPr>
+          <p:cNvPr id="20" name="Oval 19"/>
+          <p:cNvSpPr/>
+          <p:nvPr/>
+        </p:nvSpPr>
+        <p:spPr>
+          <a:xfrm>
+            <a:off x="800000" y="5080000"/>
+            <a:ext cx="60000" cy="60000"/>
+          </a:xfrm>
+          <a:prstGeom prst="ellipse">
+            <a:avLst/>
+          </a:prstGeom>
+          <a:solidFill>
+            <a:srgbClr val="9079C8"/>
+          </a:solidFill>
+          <a:ln>
+            <a:noFill/>
+          </a:ln>
+        </p:spPr>
+        <p:style>
+          <a:lnRef idx="1">
+            <a:schemeClr val="accent1"/>
+          </a:lnRef>
+          <a:fillRef idx="3">
+            <a:schemeClr val="accent1"/>
+          </a:fillRef>
+          <a:effectRef idx="2">
+            <a:schemeClr val="accent1"/>
+          </a:effectRef>
+          <a:fontRef idx="minor">
+            <a:schemeClr val="lt1"/>
+          </a:fontRef>
+        </p:style>
+        <p:txBody>
+          <a:bodyPr rtlCol="0" anchor="ctr"/>
+          <a:lstStyle/>
+          <a:p>
+            <a:pPr algn="ctr"/>
+          </a:p>
+        </p:txBody>
+      </p:sp>
+      <p:sp>
+        <p:nvSpPr>
+          <p:cNvPr id="21" name="Rectangle 20"/>
+          <p:cNvSpPr/>
+          <p:nvPr/>
+        </p:nvSpPr>
+        <p:spPr>
+          <a:xfrm>
+            <a:off x="900000" y="4870000"/>
+            <a:ext cx="10300000" cy="13716"/>
+          </a:xfrm>
+          <a:prstGeom prst="rect">
+            <a:avLst/>
+          </a:prstGeom>
+          <a:solidFill>
+            <a:srgbClr val="DFD8EC"/>
+          </a:solidFill>
+          <a:ln>
+            <a:noFill/>
+          </a:ln>
+        </p:spPr>
+        <p:style>
+          <a:lnRef idx="1">
+            <a:schemeClr val="accent1"/>
+          </a:lnRef>
+          <a:fillRef idx="3">
+            <a:schemeClr val="accent1"/>
+          </a:fillRef>
+          <a:effectRef idx="2">
+            <a:schemeClr val="accent1"/>
+          </a:effectRef>
+          <a:fontRef idx="minor">
+            <a:schemeClr val="lt1"/>
+          </a:fontRef>
+        </p:style>
+        <p:txBody>
+          <a:bodyPr rtlCol="0" anchor="ctr"/>
+          <a:lstStyle/>
+          <a:p>
+            <a:pPr algn="ctr"/>
+          </a:p>
+        </p:txBody>
+      </p:sp>
+      <p:sp>
+        <p:nvSpPr>
+          <p:cNvPr id="22" name="TextBox 21"/>
+          <p:cNvSpPr txBox="1"/>
+          <p:nvPr/>
+        </p:nvSpPr>
+        <p:spPr>
+          <a:xfrm>
+            <a:off x="920000" y="4900000"/>
+            <a:ext cx="10280000" cy="570000"/>
+          </a:xfrm>
+          <a:prstGeom prst="rect">
+            <a:avLst/>
+          </a:prstGeom>
+          <a:noFill/>
+        </p:spPr>
+        <p:txBody>
+          <a:bodyPr wrap="square">
+            <a:spAutoFit/>
+          </a:bodyPr>
+          <a:lstStyle/>
+          <a:p>
+            <a:pPr algn="l"/>
+            <a:r>
+              <a:rPr sz="1800" b="1">
+                <a:solidFill>
+                  <a:srgbClr val="9079C8"/>
+                </a:solidFill>
+              </a:rPr>
+              <a:t>(f) </a:t>
+            </a:r>
+            <a:r>
+              <a:rPr sz="1600" b="0">
+                <a:solidFill>
+                  <a:srgbClr val="4C4954"/>
+                </a:solidFill>
+              </a:rPr>
+              <a:t>Publicado entre 1 enero 2016 y 25 mayo 2026</a:t>
+            </a:r>
+          </a:p>
+        </p:txBody>
+      </p:sp>
+      <p:sp>
+        <p:nvSpPr>
+          <p:cNvPr id="23" name="TextBox 22"/>
+          <p:cNvSpPr txBox="1"/>
+          <p:nvPr/>
+        </p:nvSpPr>
+        <p:spPr>
+          <a:xfrm>
+            <a:off x="749808" y="6455664"/>
+            <a:ext cx="6858000" cy="228600"/>
+          </a:xfrm>
+          <a:prstGeom prst="rect">
+            <a:avLst/>
+          </a:prstGeom>
+          <a:noFill/>
+        </p:spPr>
+        <p:txBody>
+          <a:bodyPr wrap="square">
+            <a:spAutoFit/>
+          </a:bodyPr>
+          <a:lstStyle/>
+          <a:p>
+            <a:pPr algn="l"/>
+            <a:r>
+              <a:rPr sz="1000" b="0">
+                <a:solidFill>
+                  <a:srgbClr val="9C99A6"/>
+                </a:solidFill>
+              </a:rPr>
+              <a:t>Autoestima, autoconcepto y bienestar   -   D. Antoneac</a:t>
+            </a:r>
+          </a:p>
+        </p:txBody>
+      </p:sp>
+      <p:sp>
+        <p:nvSpPr>
+          <p:cNvPr id="24" name="Oval 23"/>
+          <p:cNvSpPr/>
+          <p:nvPr/>
+        </p:nvSpPr>
+        <p:spPr>
+          <a:xfrm>
+            <a:off x="10561320" y="6519672"/>
+            <a:ext cx="82296" cy="82296"/>
+          </a:xfrm>
+          <a:prstGeom prst="ellipse">
+            <a:avLst/>
+          </a:prstGeom>
+          <a:solidFill>
+            <a:srgbClr val="9079C8"/>
+          </a:solidFill>
+          <a:ln>
+            <a:noFill/>
+          </a:ln>
+        </p:spPr>
+        <p:style>
+          <a:lnRef idx="1">
+            <a:schemeClr val="accent1"/>
+          </a:lnRef>
+          <a:fillRef idx="3">
+            <a:schemeClr val="accent1"/>
+          </a:fillRef>
+          <a:effectRef idx="2">
+            <a:schemeClr val="accent1"/>
+          </a:effectRef>
+          <a:fontRef idx="minor">
+            <a:schemeClr val="lt1"/>
+          </a:fontRef>
+        </p:style>
+        <p:txBody>
+          <a:bodyPr rtlCol="0" anchor="ctr"/>
+          <a:lstStyle/>
+          <a:p>
+            <a:pPr algn="ctr"/>
+          </a:p>
+        </p:txBody>
+      </p:sp>
+      <p:sp>
+        <p:nvSpPr>
+          <p:cNvPr id="25" name="TextBox 24"/>
           <p:cNvSpPr txBox="1"/>
           <p:nvPr/>
         </p:nvSpPr>

</xml_diff>